<commit_message>
Add Tech Stack slide to presentation
</commit_message>
<xml_diff>
--- a/DOG_SQUAD_AI_Presentation.pptx
+++ b/DOG_SQUAD_AI_Presentation.pptx
@@ -12,9 +12,10 @@
     <p:sldId id="260" r:id="rId6"/>
     <p:sldId id="261" r:id="rId7"/>
     <p:sldId id="262" r:id="rId8"/>
+    <p:sldId id="263" r:id="rId9"/>
   </p:sldIdLst>
   <p:notesMasterIdLst>
-    <p:notesMasterId r:id="rId9"/>
+    <p:notesMasterId r:id="rId10"/>
   </p:notesMasterIdLst>
   <p:sldSz cx="9144000" cy="5143500"/>
   <p:notesSz cx="5143500" cy="9144000"/>
@@ -1060,6 +1061,94 @@
             <a:fld id="{F7021451-1387-4CA6-816F-3879F97B5CBC}" type="slidenum">
               <a:rPr lang="en-US"/>
               <a:t>7</a:t>
+            </a:fld>
+            <a:endParaRPr lang="en-US"/>
+          </a:p>
+        </p:txBody>
+      </p:sp>
+    </p:spTree>
+    <p:extLst>
+      <p:ext uri="{BB962C8B-B14F-4D97-AF65-F5344CB8AC3E}">
+        <p14:creationId xmlns:p14="http://schemas.microsoft.com/office/powerpoint/2010/main" val="1024086991"/>
+      </p:ext>
+    </p:extLst>
+  </p:cSld>
+  <p:clrMapOvr>
+    <a:masterClrMapping/>
+  </p:clrMapOvr>
+</p:notes>
+</file>
+
+<file path=ppt/notesSlides/notesSlide8.xml><?xml version="1.0" encoding="utf-8"?>
+<p:notes xmlns:a="http://schemas.openxmlformats.org/drawingml/2006/main" xmlns:r="http://schemas.openxmlformats.org/officeDocument/2006/relationships" xmlns:p="http://schemas.openxmlformats.org/presentationml/2006/main">
+  <p:cSld>
+    <p:spTree>
+      <p:nvGrpSpPr>
+        <p:cNvPr id="1" name=""/>
+        <p:cNvGrpSpPr/>
+        <p:nvPr/>
+      </p:nvGrpSpPr>
+      <p:grpSpPr>
+        <a:xfrm>
+          <a:off x="0" y="0"/>
+          <a:ext cx="0" cy="0"/>
+          <a:chOff x="0" y="0"/>
+          <a:chExt cx="0" cy="0"/>
+        </a:xfrm>
+      </p:grpSpPr>
+      <p:sp>
+        <p:nvSpPr>
+          <p:cNvPr id="2" name="Slide Image Placeholder 1"/>
+          <p:cNvSpPr>
+            <a:spLocks noGrp="1" noRot="1" noChangeAspect="1"/>
+          </p:cNvSpPr>
+          <p:nvPr>
+            <p:ph type="sldImg"/>
+          </p:nvPr>
+        </p:nvSpPr>
+        <p:spPr/>
+      </p:sp>
+      <p:sp>
+        <p:nvSpPr>
+          <p:cNvPr id="3" name="Notes Placeholder 2"/>
+          <p:cNvSpPr>
+            <a:spLocks noGrp="1"/>
+          </p:cNvSpPr>
+          <p:nvPr>
+            <p:ph type="body" idx="1"/>
+          </p:nvPr>
+        </p:nvSpPr>
+        <p:spPr/>
+        <p:txBody>
+          <a:bodyPr/>
+          <a:lstStyle/>
+          <a:p>
+            <a:r>
+              <a:rPr lang="en-US" dirty="0"/>
+              <a:t/>
+            </a:r>
+            <a:endParaRPr lang="en-US" dirty="0"/>
+          </a:p>
+        </p:txBody>
+      </p:sp>
+      <p:sp>
+        <p:nvSpPr>
+          <p:cNvPr id="4" name="Slide Number Placeholder 3"/>
+          <p:cNvSpPr>
+            <a:spLocks noGrp="1"/>
+          </p:cNvSpPr>
+          <p:nvPr>
+            <p:ph type="sldNum" sz="quarter" idx="10"/>
+          </p:nvPr>
+        </p:nvSpPr>
+        <p:spPr/>
+        <p:txBody>
+          <a:bodyPr/>
+          <a:lstStyle/>
+          <a:p>
+            <a:fld id="{F7021451-1387-4CA6-816F-3879F97B5CBC}" type="slidenum">
+              <a:rPr lang="en-US"/>
+              <a:t>8</a:t>
             </a:fld>
             <a:endParaRPr lang="en-US"/>
           </a:p>
@@ -1716,7 +1805,7 @@
                 <a:ea typeface="メイリオ" pitchFamily="34" charset="-122"/>
                 <a:cs typeface="メイリオ" pitchFamily="34" charset="-120"/>
               </a:rPr>
-              <a:t>1 / 7</a:t>
+              <a:t>1 / 8</a:t>
             </a:r>
             <a:endParaRPr lang="en-US" sz="1000" dirty="0"/>
           </a:p>
@@ -2405,7 +2494,7 @@
                 <a:ea typeface="メイリオ" pitchFamily="34" charset="-122"/>
                 <a:cs typeface="メイリオ" pitchFamily="34" charset="-120"/>
               </a:rPr>
-              <a:t>2 / 7</a:t>
+              <a:t>2 / 8</a:t>
             </a:r>
             <a:endParaRPr lang="en-US" sz="1000" dirty="0"/>
           </a:p>
@@ -3130,7 +3219,7 @@
                 <a:ea typeface="メイリオ" pitchFamily="34" charset="-122"/>
                 <a:cs typeface="メイリオ" pitchFamily="34" charset="-120"/>
               </a:rPr>
-              <a:t>3 / 7</a:t>
+              <a:t>3 / 8</a:t>
             </a:r>
             <a:endParaRPr lang="en-US" sz="1000" dirty="0"/>
           </a:p>
@@ -3802,7 +3891,7 @@
                 <a:ea typeface="メイリオ" pitchFamily="34" charset="-122"/>
                 <a:cs typeface="メイリオ" pitchFamily="34" charset="-120"/>
               </a:rPr>
-              <a:t>4 / 7</a:t>
+              <a:t>4 / 8</a:t>
             </a:r>
             <a:endParaRPr lang="en-US" sz="1000" dirty="0"/>
           </a:p>
@@ -4806,7 +4895,7 @@
                 <a:ea typeface="メイリオ" pitchFamily="34" charset="-122"/>
                 <a:cs typeface="メイリオ" pitchFamily="34" charset="-120"/>
               </a:rPr>
-              <a:t>5 / 7</a:t>
+              <a:t>5 / 8</a:t>
             </a:r>
             <a:endParaRPr lang="en-US" sz="1000" dirty="0"/>
           </a:p>
@@ -5506,7 +5595,7 @@
                 <a:ea typeface="メイリオ" pitchFamily="34" charset="-122"/>
                 <a:cs typeface="メイリオ" pitchFamily="34" charset="-120"/>
               </a:rPr>
-              <a:t>6 / 7</a:t>
+              <a:t>6 / 8</a:t>
             </a:r>
             <a:endParaRPr lang="en-US" sz="1000" dirty="0"/>
           </a:p>
@@ -5562,6 +5651,810 @@
 <file path=ppt/slides/slide7.xml><?xml version="1.0" encoding="utf-8"?>
 <p:sld xmlns:a="http://schemas.openxmlformats.org/drawingml/2006/main" xmlns:r="http://schemas.openxmlformats.org/officeDocument/2006/relationships" xmlns:p="http://schemas.openxmlformats.org/presentationml/2006/main">
   <p:cSld name="Slide 7">
+    <p:bg>
+      <p:bgPr>
+        <a:solidFill>
+          <a:srgbClr val="EFF6FF"/>
+        </a:solidFill>
+      </p:bgPr>
+    </p:bg>
+    <p:spTree>
+      <p:nvGrpSpPr>
+        <p:cNvPr id="1" name=""/>
+        <p:cNvGrpSpPr/>
+        <p:nvPr/>
+      </p:nvGrpSpPr>
+      <p:grpSpPr>
+        <a:xfrm>
+          <a:off x="0" y="0"/>
+          <a:ext cx="0" cy="0"/>
+          <a:chOff x="0" y="0"/>
+          <a:chExt cx="0" cy="0"/>
+        </a:xfrm>
+      </p:grpSpPr>
+      <p:sp>
+        <p:nvSpPr>
+          <p:cNvPr id="2" name="Shape 0"/>
+          <p:cNvSpPr/>
+          <p:nvPr/>
+        </p:nvSpPr>
+        <p:spPr>
+          <a:xfrm>
+            <a:off x="0" y="0"/>
+            <a:ext cx="9144000" cy="73152"/>
+          </a:xfrm>
+          <a:prstGeom prst="rect">
+            <a:avLst/>
+          </a:prstGeom>
+          <a:solidFill>
+            <a:srgbClr val="3B82F6"/>
+          </a:solidFill>
+          <a:ln/>
+        </p:spPr>
+      </p:sp>
+      <p:sp>
+        <p:nvSpPr>
+          <p:cNvPr id="3" name="Shape 1"/>
+          <p:cNvSpPr/>
+          <p:nvPr/>
+        </p:nvSpPr>
+        <p:spPr>
+          <a:xfrm>
+            <a:off x="0" y="73152"/>
+            <a:ext cx="9144000" cy="36576"/>
+          </a:xfrm>
+          <a:prstGeom prst="rect">
+            <a:avLst/>
+          </a:prstGeom>
+          <a:solidFill>
+            <a:srgbClr val="1E3A5F"/>
+          </a:solidFill>
+          <a:ln/>
+        </p:spPr>
+      </p:sp>
+      <p:sp>
+        <p:nvSpPr>
+          <p:cNvPr id="4" name="Shape 2"/>
+          <p:cNvSpPr/>
+          <p:nvPr/>
+        </p:nvSpPr>
+        <p:spPr>
+          <a:xfrm>
+            <a:off x="731520" y="457200"/>
+            <a:ext cx="1645920" cy="347472"/>
+          </a:xfrm>
+          <a:prstGeom prst="roundRect">
+            <a:avLst>
+              <a:gd name="adj" fmla="val 26316"/>
+            </a:avLst>
+          </a:prstGeom>
+          <a:solidFill>
+            <a:srgbClr val="3B82F6"/>
+          </a:solidFill>
+          <a:ln/>
+        </p:spPr>
+      </p:sp>
+      <p:sp>
+        <p:nvSpPr>
+          <p:cNvPr id="5" name="Text 3"/>
+          <p:cNvSpPr/>
+          <p:nvPr/>
+        </p:nvSpPr>
+        <p:spPr>
+          <a:xfrm>
+            <a:off x="731520" y="457200"/>
+            <a:ext cx="1645920" cy="347472"/>
+          </a:xfrm>
+          <a:prstGeom prst="rect">
+            <a:avLst/>
+          </a:prstGeom>
+          <a:noFill/>
+          <a:ln/>
+        </p:spPr>
+        <p:txBody>
+          <a:bodyPr wrap="square" rtlCol="0" anchor="ctr"/>
+          <a:lstStyle/>
+          <a:p>
+            <a:pPr algn="ctr" indent="0" marL="0">
+              <a:buNone/>
+            </a:pPr>
+            <a:r>
+              <a:rPr lang="en-US" sz="1100" b="1" dirty="0">
+                <a:solidFill>
+                  <a:srgbClr val="FFFFFF"/>
+                </a:solidFill>
+                <a:latin typeface="メイリオ" pitchFamily="34" charset="0"/>
+                <a:ea typeface="メイリオ" pitchFamily="34" charset="-122"/>
+                <a:cs typeface="メイリオ" pitchFamily="34" charset="-120"/>
+              </a:rPr>
+              <a:t>TECH STACK</a:t>
+            </a:r>
+            <a:endParaRPr lang="en-US" sz="1100" dirty="0"/>
+          </a:p>
+        </p:txBody>
+      </p:sp>
+      <p:sp>
+        <p:nvSpPr>
+          <p:cNvPr id="6" name="Text 4"/>
+          <p:cNvSpPr/>
+          <p:nvPr/>
+        </p:nvSpPr>
+        <p:spPr>
+          <a:xfrm>
+            <a:off x="2743200" y="411480"/>
+            <a:ext cx="8229600" cy="457200"/>
+          </a:xfrm>
+          <a:prstGeom prst="rect">
+            <a:avLst/>
+          </a:prstGeom>
+          <a:noFill/>
+          <a:ln/>
+        </p:spPr>
+        <p:txBody>
+          <a:bodyPr wrap="square" rtlCol="0" anchor="ctr"/>
+          <a:lstStyle/>
+          <a:p>
+            <a:pPr indent="0" marL="0">
+              <a:buNone/>
+            </a:pPr>
+            <a:r>
+              <a:rPr lang="en-US" sz="2200" b="1" dirty="0">
+                <a:solidFill>
+                  <a:srgbClr val="1E3A5F"/>
+                </a:solidFill>
+                <a:latin typeface="メイリオ" pitchFamily="34" charset="0"/>
+                <a:ea typeface="メイリオ" pitchFamily="34" charset="-122"/>
+                <a:cs typeface="メイリオ" pitchFamily="34" charset="-120"/>
+              </a:rPr>
+              <a:t>プロジェクトを支える使用技術</a:t>
+            </a:r>
+            <a:endParaRPr lang="en-US" sz="2200" dirty="0"/>
+          </a:p>
+        </p:txBody>
+      </p:sp>
+      <p:sp>
+        <p:nvSpPr>
+          <p:cNvPr id="7" name="Shape 5"/>
+          <p:cNvSpPr/>
+          <p:nvPr/>
+        </p:nvSpPr>
+        <p:spPr>
+          <a:xfrm>
+            <a:off x="731520" y="1280160"/>
+            <a:ext cx="5120640" cy="4114800"/>
+          </a:xfrm>
+          <a:prstGeom prst="roundRect">
+            <a:avLst>
+              <a:gd name="adj" fmla="val 2222"/>
+            </a:avLst>
+          </a:prstGeom>
+          <a:solidFill>
+            <a:srgbClr val="FFFFFF"/>
+          </a:solidFill>
+          <a:ln/>
+          <a:effectLst>
+            <a:outerShdw sx="100000" sy="100000" kx="0" ky="0" algn="bl" rotWithShape="0" blurRad="50800" dist="12700" dir="16200000">
+              <a:srgbClr val="00000015">
+                <a:alpha val="75000"/>
+              </a:srgbClr>
+            </a:outerShdw>
+          </a:effectLst>
+        </p:spPr>
+      </p:sp>
+      <p:sp>
+        <p:nvSpPr>
+          <p:cNvPr id="8" name="Text 6"/>
+          <p:cNvSpPr/>
+          <p:nvPr/>
+        </p:nvSpPr>
+        <p:spPr>
+          <a:xfrm>
+            <a:off x="1005840" y="1463040"/>
+            <a:ext cx="4572000" cy="365760"/>
+          </a:xfrm>
+          <a:prstGeom prst="rect">
+            <a:avLst/>
+          </a:prstGeom>
+          <a:noFill/>
+          <a:ln/>
+        </p:spPr>
+        <p:txBody>
+          <a:bodyPr wrap="square" rtlCol="0" anchor="ctr"/>
+          <a:lstStyle/>
+          <a:p>
+            <a:pPr indent="0" marL="0">
+              <a:buNone/>
+            </a:pPr>
+            <a:r>
+              <a:rPr lang="en-US" sz="1400" b="1" dirty="0">
+                <a:solidFill>
+                  <a:srgbClr val="1E3A5F"/>
+                </a:solidFill>
+                <a:latin typeface="メイリオ" pitchFamily="34" charset="0"/>
+                <a:ea typeface="メイリオ" pitchFamily="34" charset="-122"/>
+                <a:cs typeface="メイリオ" pitchFamily="34" charset="-120"/>
+              </a:rPr>
+              <a:t>🎨 フロントエンド ＆ ゲームエンジン</a:t>
+            </a:r>
+            <a:endParaRPr lang="en-US" sz="1400" dirty="0"/>
+          </a:p>
+        </p:txBody>
+      </p:sp>
+      <p:sp>
+        <p:nvSpPr>
+          <p:cNvPr id="9" name="Text 7"/>
+          <p:cNvSpPr/>
+          <p:nvPr/>
+        </p:nvSpPr>
+        <p:spPr>
+          <a:xfrm>
+            <a:off x="1005840" y="2011680"/>
+            <a:ext cx="4572000" cy="3200400"/>
+          </a:xfrm>
+          <a:prstGeom prst="rect">
+            <a:avLst/>
+          </a:prstGeom>
+          <a:noFill/>
+          <a:ln/>
+        </p:spPr>
+        <p:txBody>
+          <a:bodyPr wrap="square" rtlCol="0" anchor="ctr"/>
+          <a:lstStyle/>
+          <a:p>
+            <a:pPr indent="0" marL="0">
+              <a:lnSpc>
+                <a:spcPts val="1800"/>
+              </a:lnSpc>
+              <a:buNone/>
+            </a:pPr>
+            <a:r>
+              <a:rPr lang="en-US" sz="1200" dirty="0">
+                <a:solidFill>
+                  <a:srgbClr val="1E293B"/>
+                </a:solidFill>
+                <a:latin typeface="メイリオ" pitchFamily="34" charset="0"/>
+                <a:ea typeface="メイリオ" pitchFamily="34" charset="-122"/>
+                <a:cs typeface="メイリオ" pitchFamily="34" charset="-120"/>
+              </a:rPr>
+              <a:t>■ HTML / CSS</a:t>
+            </a:r>
+            <a:endParaRPr lang="en-US" sz="1200" dirty="0"/>
+          </a:p>
+          <a:p>
+            <a:pPr indent="0" marL="0">
+              <a:lnSpc>
+                <a:spcPts val="1800"/>
+              </a:lnSpc>
+              <a:buNone/>
+            </a:pPr>
+            <a:r>
+              <a:rPr lang="en-US" sz="1200" dirty="0">
+                <a:solidFill>
+                  <a:srgbClr val="1E293B"/>
+                </a:solidFill>
+                <a:latin typeface="メイリオ" pitchFamily="34" charset="0"/>
+                <a:ea typeface="メイリオ" pitchFamily="34" charset="-122"/>
+                <a:cs typeface="メイリオ" pitchFamily="34" charset="-120"/>
+              </a:rPr>
+              <a:t>UIやキャラクターアイコンなどをすべてCSSアートで独自描画しています。</a:t>
+            </a:r>
+            <a:endParaRPr lang="en-US" sz="1200" dirty="0"/>
+          </a:p>
+          <a:p>
+            <a:pPr indent="0" marL="0">
+              <a:lnSpc>
+                <a:spcPts val="1800"/>
+              </a:lnSpc>
+              <a:buNone/>
+            </a:pPr>
+            <a:endParaRPr lang="en-US" sz="1200" dirty="0"/>
+          </a:p>
+          <a:p>
+            <a:pPr indent="0" marL="0">
+              <a:lnSpc>
+                <a:spcPts val="1800"/>
+              </a:lnSpc>
+              <a:buNone/>
+            </a:pPr>
+            <a:r>
+              <a:rPr lang="en-US" sz="1200" dirty="0">
+                <a:solidFill>
+                  <a:srgbClr val="1E293B"/>
+                </a:solidFill>
+                <a:latin typeface="メイリオ" pitchFamily="34" charset="0"/>
+                <a:ea typeface="メイリオ" pitchFamily="34" charset="-122"/>
+                <a:cs typeface="メイリオ" pitchFamily="34" charset="-120"/>
+              </a:rPr>
+              <a:t>■ JavaScript</a:t>
+            </a:r>
+            <a:endParaRPr lang="en-US" sz="1200" dirty="0"/>
+          </a:p>
+          <a:p>
+            <a:pPr indent="0" marL="0">
+              <a:lnSpc>
+                <a:spcPts val="1800"/>
+              </a:lnSpc>
+              <a:buNone/>
+            </a:pPr>
+            <a:r>
+              <a:rPr lang="en-US" sz="1200" dirty="0">
+                <a:solidFill>
+                  <a:srgbClr val="1E293B"/>
+                </a:solidFill>
+                <a:latin typeface="メイリオ" pitchFamily="34" charset="0"/>
+                <a:ea typeface="メイリオ" pitchFamily="34" charset="-122"/>
+                <a:cs typeface="メイリオ" pitchFamily="34" charset="-120"/>
+              </a:rPr>
+              <a:t>ゲームのメインロジック、通信処理、AIの推論をブラウザ上で実行します。</a:t>
+            </a:r>
+            <a:endParaRPr lang="en-US" sz="1200" dirty="0"/>
+          </a:p>
+          <a:p>
+            <a:pPr indent="0" marL="0">
+              <a:lnSpc>
+                <a:spcPts val="1800"/>
+              </a:lnSpc>
+              <a:buNone/>
+            </a:pPr>
+            <a:endParaRPr lang="en-US" sz="1200" dirty="0"/>
+          </a:p>
+          <a:p>
+            <a:pPr indent="0" marL="0">
+              <a:lnSpc>
+                <a:spcPts val="1800"/>
+              </a:lnSpc>
+              <a:buNone/>
+            </a:pPr>
+            <a:r>
+              <a:rPr lang="en-US" sz="1200" dirty="0">
+                <a:solidFill>
+                  <a:srgbClr val="1E293B"/>
+                </a:solidFill>
+                <a:latin typeface="メイリオ" pitchFamily="34" charset="0"/>
+                <a:ea typeface="メイリオ" pitchFamily="34" charset="-122"/>
+                <a:cs typeface="メイリオ" pitchFamily="34" charset="-120"/>
+              </a:rPr>
+              <a:t>■ Three.js</a:t>
+            </a:r>
+            <a:endParaRPr lang="en-US" sz="1200" dirty="0"/>
+          </a:p>
+          <a:p>
+            <a:pPr indent="0" marL="0">
+              <a:lnSpc>
+                <a:spcPts val="1800"/>
+              </a:lnSpc>
+              <a:buNone/>
+            </a:pPr>
+            <a:r>
+              <a:rPr lang="en-US" sz="1200" dirty="0">
+                <a:solidFill>
+                  <a:srgbClr val="1E293B"/>
+                </a:solidFill>
+                <a:latin typeface="メイリオ" pitchFamily="34" charset="0"/>
+                <a:ea typeface="メイリオ" pitchFamily="34" charset="-122"/>
+                <a:cs typeface="メイリオ" pitchFamily="34" charset="-120"/>
+              </a:rPr>
+              <a:t>迫力ある3Dグラフィックスをブラウザ上で軽量にレンダリングします。</a:t>
+            </a:r>
+            <a:endParaRPr lang="en-US" sz="1200" dirty="0"/>
+          </a:p>
+          <a:p>
+            <a:pPr indent="0" marL="0">
+              <a:lnSpc>
+                <a:spcPts val="1800"/>
+              </a:lnSpc>
+              <a:buNone/>
+            </a:pPr>
+            <a:endParaRPr lang="en-US" sz="1200" dirty="0"/>
+          </a:p>
+          <a:p>
+            <a:pPr indent="0" marL="0">
+              <a:lnSpc>
+                <a:spcPts val="1800"/>
+              </a:lnSpc>
+              <a:buNone/>
+            </a:pPr>
+            <a:r>
+              <a:rPr lang="en-US" sz="1200" dirty="0">
+                <a:solidFill>
+                  <a:srgbClr val="1E293B"/>
+                </a:solidFill>
+                <a:latin typeface="メイリオ" pitchFamily="34" charset="0"/>
+                <a:ea typeface="メイリオ" pitchFamily="34" charset="-122"/>
+                <a:cs typeface="メイリオ" pitchFamily="34" charset="-120"/>
+              </a:rPr>
+              <a:t>■ Web Audio API</a:t>
+            </a:r>
+            <a:endParaRPr lang="en-US" sz="1200" dirty="0"/>
+          </a:p>
+          <a:p>
+            <a:pPr indent="0" marL="0">
+              <a:lnSpc>
+                <a:spcPts val="1800"/>
+              </a:lnSpc>
+              <a:buNone/>
+            </a:pPr>
+            <a:r>
+              <a:rPr lang="en-US" sz="1200" dirty="0">
+                <a:solidFill>
+                  <a:srgbClr val="1E293B"/>
+                </a:solidFill>
+                <a:latin typeface="メイリオ" pitchFamily="34" charset="0"/>
+                <a:ea typeface="メイリオ" pitchFamily="34" charset="-122"/>
+                <a:cs typeface="メイリオ" pitchFamily="34" charset="-120"/>
+              </a:rPr>
+              <a:t>BGMや効果音をリアルタイムにプログラムで合成・再生します。</a:t>
+            </a:r>
+            <a:endParaRPr lang="en-US" sz="1200" dirty="0"/>
+          </a:p>
+        </p:txBody>
+      </p:sp>
+      <p:sp>
+        <p:nvSpPr>
+          <p:cNvPr id="10" name="Shape 8"/>
+          <p:cNvSpPr/>
+          <p:nvPr/>
+        </p:nvSpPr>
+        <p:spPr>
+          <a:xfrm>
+            <a:off x="6217920" y="1280160"/>
+            <a:ext cx="5120640" cy="4114800"/>
+          </a:xfrm>
+          <a:prstGeom prst="roundRect">
+            <a:avLst>
+              <a:gd name="adj" fmla="val 2222"/>
+            </a:avLst>
+          </a:prstGeom>
+          <a:solidFill>
+            <a:srgbClr val="FFFFFF"/>
+          </a:solidFill>
+          <a:ln/>
+          <a:effectLst>
+            <a:outerShdw sx="100000" sy="100000" kx="0" ky="0" algn="bl" rotWithShape="0" blurRad="50800" dist="12700" dir="16200000">
+              <a:srgbClr val="00000015">
+                <a:alpha val="75000"/>
+              </a:srgbClr>
+            </a:outerShdw>
+          </a:effectLst>
+        </p:spPr>
+      </p:sp>
+      <p:sp>
+        <p:nvSpPr>
+          <p:cNvPr id="11" name="Text 9"/>
+          <p:cNvSpPr/>
+          <p:nvPr/>
+        </p:nvSpPr>
+        <p:spPr>
+          <a:xfrm>
+            <a:off x="6492240" y="1463040"/>
+            <a:ext cx="4572000" cy="365760"/>
+          </a:xfrm>
+          <a:prstGeom prst="rect">
+            <a:avLst/>
+          </a:prstGeom>
+          <a:noFill/>
+          <a:ln/>
+        </p:spPr>
+        <p:txBody>
+          <a:bodyPr wrap="square" rtlCol="0" anchor="ctr"/>
+          <a:lstStyle/>
+          <a:p>
+            <a:pPr indent="0" marL="0">
+              <a:buNone/>
+            </a:pPr>
+            <a:r>
+              <a:rPr lang="en-US" sz="1400" b="1" dirty="0">
+                <a:solidFill>
+                  <a:srgbClr val="1E3A5F"/>
+                </a:solidFill>
+                <a:latin typeface="メイリオ" pitchFamily="34" charset="0"/>
+                <a:ea typeface="メイリオ" pitchFamily="34" charset="-122"/>
+                <a:cs typeface="メイリオ" pitchFamily="34" charset="-120"/>
+              </a:rPr>
+              <a:t>☁️ バックエンド ＆ 機械学習</a:t>
+            </a:r>
+            <a:endParaRPr lang="en-US" sz="1400" dirty="0"/>
+          </a:p>
+        </p:txBody>
+      </p:sp>
+      <p:sp>
+        <p:nvSpPr>
+          <p:cNvPr id="12" name="Text 10"/>
+          <p:cNvSpPr/>
+          <p:nvPr/>
+        </p:nvSpPr>
+        <p:spPr>
+          <a:xfrm>
+            <a:off x="6492240" y="2011680"/>
+            <a:ext cx="4572000" cy="3200400"/>
+          </a:xfrm>
+          <a:prstGeom prst="rect">
+            <a:avLst/>
+          </a:prstGeom>
+          <a:noFill/>
+          <a:ln/>
+        </p:spPr>
+        <p:txBody>
+          <a:bodyPr wrap="square" rtlCol="0" anchor="ctr"/>
+          <a:lstStyle/>
+          <a:p>
+            <a:pPr indent="0" marL="0">
+              <a:lnSpc>
+                <a:spcPts val="1800"/>
+              </a:lnSpc>
+              <a:buNone/>
+            </a:pPr>
+            <a:r>
+              <a:rPr lang="en-US" sz="1200" dirty="0">
+                <a:solidFill>
+                  <a:srgbClr val="1E293B"/>
+                </a:solidFill>
+                <a:latin typeface="メイリオ" pitchFamily="34" charset="0"/>
+                <a:ea typeface="メイリオ" pitchFamily="34" charset="-122"/>
+                <a:cs typeface="メイリオ" pitchFamily="34" charset="-120"/>
+              </a:rPr>
+              <a:t>■ Firebase Firestore</a:t>
+            </a:r>
+            <a:endParaRPr lang="en-US" sz="1200" dirty="0"/>
+          </a:p>
+          <a:p>
+            <a:pPr indent="0" marL="0">
+              <a:lnSpc>
+                <a:spcPts val="1800"/>
+              </a:lnSpc>
+              <a:buNone/>
+            </a:pPr>
+            <a:r>
+              <a:rPr lang="en-US" sz="1200" dirty="0">
+                <a:solidFill>
+                  <a:srgbClr val="1E293B"/>
+                </a:solidFill>
+                <a:latin typeface="メイリオ" pitchFamily="34" charset="0"/>
+                <a:ea typeface="メイリオ" pitchFamily="34" charset="-122"/>
+                <a:cs typeface="メイリオ" pitchFamily="34" charset="-120"/>
+              </a:rPr>
+              <a:t>サーバーを立てずに、プレイヤーの戦績データの保存や、最大6人のリアルタイムオンライン対戦を実現しています。</a:t>
+            </a:r>
+            <a:endParaRPr lang="en-US" sz="1200" dirty="0"/>
+          </a:p>
+          <a:p>
+            <a:pPr indent="0" marL="0">
+              <a:lnSpc>
+                <a:spcPts val="1800"/>
+              </a:lnSpc>
+              <a:buNone/>
+            </a:pPr>
+            <a:endParaRPr lang="en-US" sz="1200" dirty="0"/>
+          </a:p>
+          <a:p>
+            <a:pPr indent="0" marL="0">
+              <a:lnSpc>
+                <a:spcPts val="1800"/>
+              </a:lnSpc>
+              <a:buNone/>
+            </a:pPr>
+            <a:r>
+              <a:rPr lang="en-US" sz="1200" dirty="0">
+                <a:solidFill>
+                  <a:srgbClr val="1E293B"/>
+                </a:solidFill>
+                <a:latin typeface="メイリオ" pitchFamily="34" charset="0"/>
+                <a:ea typeface="メイリオ" pitchFamily="34" charset="-122"/>
+                <a:cs typeface="メイリオ" pitchFamily="34" charset="-120"/>
+              </a:rPr>
+              <a:t>■ Firebase Hosting</a:t>
+            </a:r>
+            <a:endParaRPr lang="en-US" sz="1200" dirty="0"/>
+          </a:p>
+          <a:p>
+            <a:pPr indent="0" marL="0">
+              <a:lnSpc>
+                <a:spcPts val="1800"/>
+              </a:lnSpc>
+              <a:buNone/>
+            </a:pPr>
+            <a:r>
+              <a:rPr lang="en-US" sz="1200" dirty="0">
+                <a:solidFill>
+                  <a:srgbClr val="1E293B"/>
+                </a:solidFill>
+                <a:latin typeface="メイリオ" pitchFamily="34" charset="0"/>
+                <a:ea typeface="メイリオ" pitchFamily="34" charset="-122"/>
+                <a:cs typeface="メイリオ" pitchFamily="34" charset="-120"/>
+              </a:rPr>
+              <a:t>ゲームをインターネットに公開し、誰でもすぐ遊べる環境を提供しています。</a:t>
+            </a:r>
+            <a:endParaRPr lang="en-US" sz="1200" dirty="0"/>
+          </a:p>
+          <a:p>
+            <a:pPr indent="0" marL="0">
+              <a:lnSpc>
+                <a:spcPts val="1800"/>
+              </a:lnSpc>
+              <a:buNone/>
+            </a:pPr>
+            <a:endParaRPr lang="en-US" sz="1200" dirty="0"/>
+          </a:p>
+          <a:p>
+            <a:pPr indent="0" marL="0">
+              <a:lnSpc>
+                <a:spcPts val="1800"/>
+              </a:lnSpc>
+              <a:buNone/>
+            </a:pPr>
+            <a:r>
+              <a:rPr lang="en-US" sz="1200" dirty="0">
+                <a:solidFill>
+                  <a:srgbClr val="1E293B"/>
+                </a:solidFill>
+                <a:latin typeface="メイリオ" pitchFamily="34" charset="0"/>
+                <a:ea typeface="メイリオ" pitchFamily="34" charset="-122"/>
+                <a:cs typeface="メイリオ" pitchFamily="34" charset="-120"/>
+              </a:rPr>
+              <a:t>■ TensorFlow.js</a:t>
+            </a:r>
+            <a:endParaRPr lang="en-US" sz="1200" dirty="0"/>
+          </a:p>
+          <a:p>
+            <a:pPr indent="0" marL="0">
+              <a:lnSpc>
+                <a:spcPts val="1800"/>
+              </a:lnSpc>
+              <a:buNone/>
+            </a:pPr>
+            <a:r>
+              <a:rPr lang="en-US" sz="1200" dirty="0">
+                <a:solidFill>
+                  <a:srgbClr val="1E293B"/>
+                </a:solidFill>
+                <a:latin typeface="メイリオ" pitchFamily="34" charset="0"/>
+                <a:ea typeface="メイリオ" pitchFamily="34" charset="-122"/>
+                <a:cs typeface="メイリオ" pitchFamily="34" charset="-120"/>
+              </a:rPr>
+              <a:t>学習済みのAI頭脳をブラウザに読み込み、高速に難易度を予測します。</a:t>
+            </a:r>
+            <a:endParaRPr lang="en-US" sz="1200" dirty="0"/>
+          </a:p>
+          <a:p>
+            <a:pPr indent="0" marL="0">
+              <a:lnSpc>
+                <a:spcPts val="1800"/>
+              </a:lnSpc>
+              <a:buNone/>
+            </a:pPr>
+            <a:endParaRPr lang="en-US" sz="1200" dirty="0"/>
+          </a:p>
+          <a:p>
+            <a:pPr indent="0" marL="0">
+              <a:lnSpc>
+                <a:spcPts val="1800"/>
+              </a:lnSpc>
+              <a:buNone/>
+            </a:pPr>
+            <a:r>
+              <a:rPr lang="en-US" sz="1200" dirty="0">
+                <a:solidFill>
+                  <a:srgbClr val="1E293B"/>
+                </a:solidFill>
+                <a:latin typeface="メイリオ" pitchFamily="34" charset="0"/>
+                <a:ea typeface="メイリオ" pitchFamily="34" charset="-122"/>
+                <a:cs typeface="メイリオ" pitchFamily="34" charset="-120"/>
+              </a:rPr>
+              <a:t>■ Python (Google Colab)</a:t>
+            </a:r>
+            <a:endParaRPr lang="en-US" sz="1200" dirty="0"/>
+          </a:p>
+          <a:p>
+            <a:pPr indent="0" marL="0">
+              <a:lnSpc>
+                <a:spcPts val="1800"/>
+              </a:lnSpc>
+              <a:buNone/>
+            </a:pPr>
+            <a:r>
+              <a:rPr lang="en-US" sz="1200" dirty="0">
+                <a:solidFill>
+                  <a:srgbClr val="1E293B"/>
+                </a:solidFill>
+                <a:latin typeface="メイリオ" pitchFamily="34" charset="0"/>
+                <a:ea typeface="メイリオ" pitchFamily="34" charset="-122"/>
+                <a:cs typeface="メイリオ" pitchFamily="34" charset="-120"/>
+              </a:rPr>
+              <a:t>189件のデータからAIモデルを訓練し、精度をグラフ化・検証しました。</a:t>
+            </a:r>
+            <a:endParaRPr lang="en-US" sz="1200" dirty="0"/>
+          </a:p>
+        </p:txBody>
+      </p:sp>
+      <p:sp>
+        <p:nvSpPr>
+          <p:cNvPr id="13" name="Text 11"/>
+          <p:cNvSpPr/>
+          <p:nvPr/>
+        </p:nvSpPr>
+        <p:spPr>
+          <a:xfrm>
+            <a:off x="10515600" y="6400800"/>
+            <a:ext cx="1371600" cy="274320"/>
+          </a:xfrm>
+          <a:prstGeom prst="rect">
+            <a:avLst/>
+          </a:prstGeom>
+          <a:noFill/>
+          <a:ln/>
+        </p:spPr>
+        <p:txBody>
+          <a:bodyPr wrap="square" rtlCol="0" anchor="ctr"/>
+          <a:lstStyle/>
+          <a:p>
+            <a:pPr algn="r" indent="0" marL="0">
+              <a:buNone/>
+            </a:pPr>
+            <a:r>
+              <a:rPr lang="en-US" sz="1000" dirty="0">
+                <a:solidFill>
+                  <a:srgbClr val="64748B"/>
+                </a:solidFill>
+                <a:latin typeface="メイリオ" pitchFamily="34" charset="0"/>
+                <a:ea typeface="メイリオ" pitchFamily="34" charset="-122"/>
+                <a:cs typeface="メイリオ" pitchFamily="34" charset="-120"/>
+              </a:rPr>
+              <a:t>7 / 8</a:t>
+            </a:r>
+            <a:endParaRPr lang="en-US" sz="1000" dirty="0"/>
+          </a:p>
+        </p:txBody>
+      </p:sp>
+      <p:sp>
+        <p:nvSpPr>
+          <p:cNvPr id="14" name="Text 12"/>
+          <p:cNvSpPr/>
+          <p:nvPr/>
+        </p:nvSpPr>
+        <p:spPr>
+          <a:xfrm>
+            <a:off x="457200" y="6400800"/>
+            <a:ext cx="5486400" cy="274320"/>
+          </a:xfrm>
+          <a:prstGeom prst="rect">
+            <a:avLst/>
+          </a:prstGeom>
+          <a:noFill/>
+          <a:ln/>
+        </p:spPr>
+        <p:txBody>
+          <a:bodyPr wrap="square" rtlCol="0" anchor="ctr"/>
+          <a:lstStyle/>
+          <a:p>
+            <a:pPr indent="0" marL="0">
+              <a:buNone/>
+            </a:pPr>
+            <a:r>
+              <a:rPr lang="en-US" sz="900" dirty="0">
+                <a:solidFill>
+                  <a:srgbClr val="64748B"/>
+                </a:solidFill>
+                <a:latin typeface="メイリオ" pitchFamily="34" charset="0"/>
+                <a:ea typeface="メイリオ" pitchFamily="34" charset="-122"/>
+                <a:cs typeface="メイリオ" pitchFamily="34" charset="-120"/>
+              </a:rPr>
+              <a:t>DOG SQUAD: SQUIRREL SIEGE — DDA × AI プロジェクト</a:t>
+            </a:r>
+            <a:endParaRPr lang="en-US" sz="900" dirty="0"/>
+          </a:p>
+        </p:txBody>
+      </p:sp>
+    </p:spTree>
+  </p:cSld>
+  <p:clrMapOvr>
+    <a:masterClrMapping/>
+  </p:clrMapOvr>
+</p:sld>
+</file>
+
+<file path=ppt/slides/slide8.xml><?xml version="1.0" encoding="utf-8"?>
+<p:sld xmlns:a="http://schemas.openxmlformats.org/drawingml/2006/main" xmlns:r="http://schemas.openxmlformats.org/officeDocument/2006/relationships" xmlns:p="http://schemas.openxmlformats.org/presentationml/2006/main">
+  <p:cSld name="Slide 8">
     <p:bg>
       <p:bgPr>
         <a:solidFill>
@@ -6048,7 +6941,7 @@
                 <a:ea typeface="メイリオ" pitchFamily="34" charset="-122"/>
                 <a:cs typeface="メイリオ" pitchFamily="34" charset="-120"/>
               </a:rPr>
-              <a:t>7 / 7</a:t>
+              <a:t>8 / 8</a:t>
             </a:r>
             <a:endParaRPr lang="en-US" sz="1000" dirty="0"/>
           </a:p>

</xml_diff>